<commit_message>
fix(scripts): add yellow text highlight to arial/font-grid diagnostic decks
Missed carrying the `highlight: 'FFFF00'` convention (established in
gen-line-spacing.ts / gen-textframe-fit.ts) over to gen-arial-diagnostic.ts
and gen-font-grid-diagnostic.ts when those switched to underline for the
baseline reference line — both now carry underline + yellow highlight
together.

Co-Authored-By: Claude Sonnet 5 <noreply@anthropic.com>
</commit_message>
<xml_diff>
--- a/scripts/office-metrics/arial-diagnostic.pptx
+++ b/scripts/office-metrics/arial-diagnostic.pptx
@@ -870,7 +870,7 @@
       </p:grpSpPr>
       <p:sp>
         <p:nvSpPr>
-          <p:cNvPr id="2" name="arial-12__c14.40_t13.54"/>
+          <p:cNvPr id="2" name="arial-12__c14.40_t13.91"/>
           <p:cNvSpPr/>
           <p:nvPr/>
         </p:nvSpPr>
@@ -904,6 +904,9 @@
                 <a:solidFill>
                   <a:srgbClr val="000000"/>
                 </a:solidFill>
+                <a:highlight>
+                  <a:srgbClr val="FFFF00"/>
+                </a:highlight>
                 <a:latin typeface="Arial" pitchFamily="34" charset="0"/>
                 <a:ea typeface="Arial" pitchFamily="34" charset="-122"/>
                 <a:cs typeface="Arial" pitchFamily="34" charset="-120"/>
@@ -922,7 +925,7 @@
         </p:nvSpPr>
         <p:spPr>
           <a:xfrm>
-            <a:off x="365760" y="622808"/>
+            <a:off x="365760" y="627507"/>
             <a:ext cx="2033143" cy="12700"/>
           </a:xfrm>
           <a:prstGeom prst="rect">
@@ -936,7 +939,7 @@
       </p:sp>
       <p:sp>
         <p:nvSpPr>
-          <p:cNvPr id="4" name="arial-18__c21.60_t20.31"/>
+          <p:cNvPr id="4" name="arial-18__c21.60_t20.87"/>
           <p:cNvSpPr/>
           <p:nvPr/>
         </p:nvSpPr>
@@ -970,6 +973,9 @@
                 <a:solidFill>
                   <a:srgbClr val="000000"/>
                 </a:solidFill>
+                <a:highlight>
+                  <a:srgbClr val="FFFF00"/>
+                </a:highlight>
                 <a:latin typeface="Arial" pitchFamily="34" charset="0"/>
                 <a:ea typeface="Arial" pitchFamily="34" charset="-122"/>
                 <a:cs typeface="Arial" pitchFamily="34" charset="-120"/>
@@ -988,7 +994,7 @@
         </p:nvSpPr>
         <p:spPr>
           <a:xfrm>
-            <a:off x="2703703" y="708787"/>
+            <a:off x="2703703" y="715899"/>
             <a:ext cx="3278886" cy="12700"/>
           </a:xfrm>
           <a:prstGeom prst="rect">
@@ -1002,7 +1008,7 @@
       </p:sp>
       <p:sp>
         <p:nvSpPr>
-          <p:cNvPr id="6" name="arial-24__c28.80_t27.08"/>
+          <p:cNvPr id="6" name="arial-24__c28.80_t27.82"/>
           <p:cNvSpPr/>
           <p:nvPr/>
         </p:nvSpPr>
@@ -1036,6 +1042,9 @@
                 <a:solidFill>
                   <a:srgbClr val="000000"/>
                 </a:solidFill>
+                <a:highlight>
+                  <a:srgbClr val="FFFF00"/>
+                </a:highlight>
                 <a:latin typeface="Arial" pitchFamily="34" charset="0"/>
                 <a:ea typeface="Arial" pitchFamily="34" charset="-122"/>
                 <a:cs typeface="Arial" pitchFamily="34" charset="-120"/>
@@ -1054,7 +1063,7 @@
         </p:nvSpPr>
         <p:spPr>
           <a:xfrm>
-            <a:off x="6287389" y="794766"/>
+            <a:off x="6287389" y="804164"/>
             <a:ext cx="3049905" cy="12700"/>
           </a:xfrm>
           <a:prstGeom prst="rect">
@@ -1068,7 +1077,7 @@
       </p:sp>
       <p:sp>
         <p:nvSpPr>
-          <p:cNvPr id="8" name="arial-32__c38.40_t36.11"/>
+          <p:cNvPr id="8" name="arial-32__c38.40_t37.10"/>
           <p:cNvSpPr/>
           <p:nvPr/>
         </p:nvSpPr>
@@ -1102,6 +1111,9 @@
                 <a:solidFill>
                   <a:srgbClr val="000000"/>
                 </a:solidFill>
+                <a:highlight>
+                  <a:srgbClr val="FFFF00"/>
+                </a:highlight>
                 <a:latin typeface="Arial" pitchFamily="34" charset="0"/>
                 <a:ea typeface="Arial" pitchFamily="34" charset="-122"/>
                 <a:cs typeface="Arial" pitchFamily="34" charset="-120"/>
@@ -1120,7 +1132,7 @@
         </p:nvSpPr>
         <p:spPr>
           <a:xfrm>
-            <a:off x="9642094" y="909447"/>
+            <a:off x="9642094" y="922020"/>
             <a:ext cx="4066540" cy="12700"/>
           </a:xfrm>
           <a:prstGeom prst="rect">
@@ -1134,7 +1146,7 @@
       </p:sp>
       <p:sp>
         <p:nvSpPr>
-          <p:cNvPr id="10" name="arial-40-bold__c48.00_t45.14"/>
+          <p:cNvPr id="10" name="arial-40-bold__c48.00_t46.38"/>
           <p:cNvSpPr/>
           <p:nvPr/>
         </p:nvSpPr>
@@ -1168,6 +1180,9 @@
                 <a:solidFill>
                   <a:srgbClr val="000000"/>
                 </a:solidFill>
+                <a:highlight>
+                  <a:srgbClr val="FFFF00"/>
+                </a:highlight>
                 <a:latin typeface="Arial" pitchFamily="34" charset="0"/>
                 <a:ea typeface="Arial" pitchFamily="34" charset="-122"/>
                 <a:cs typeface="Arial" pitchFamily="34" charset="-120"/>
@@ -1186,7 +1201,7 @@
         </p:nvSpPr>
         <p:spPr>
           <a:xfrm>
-            <a:off x="14013434" y="1024128"/>
+            <a:off x="14013434" y="1039876"/>
             <a:ext cx="5966968" cy="12700"/>
           </a:xfrm>
           <a:prstGeom prst="rect">
@@ -1200,7 +1215,7 @@
       </p:sp>
       <p:sp>
         <p:nvSpPr>
-          <p:cNvPr id="12" name="arial-mixed-12-32__c38.40_t36.11"/>
+          <p:cNvPr id="12" name="arial-mixed-12-32__c38.40_t37.10"/>
           <p:cNvSpPr/>
           <p:nvPr/>
         </p:nvSpPr>
@@ -1234,6 +1249,9 @@
                 <a:solidFill>
                   <a:srgbClr val="000000"/>
                 </a:solidFill>
+                <a:highlight>
+                  <a:srgbClr val="FFFF00"/>
+                </a:highlight>
                 <a:latin typeface="Arial" pitchFamily="34" charset="0"/>
                 <a:ea typeface="Arial" pitchFamily="34" charset="-122"/>
                 <a:cs typeface="Arial" pitchFamily="34" charset="-120"/>
@@ -1251,6 +1269,9 @@
                 <a:solidFill>
                   <a:srgbClr val="000000"/>
                 </a:solidFill>
+                <a:highlight>
+                  <a:srgbClr val="FFFF00"/>
+                </a:highlight>
                 <a:latin typeface="Arial" pitchFamily="34" charset="0"/>
                 <a:ea typeface="Arial" pitchFamily="34" charset="-122"/>
                 <a:cs typeface="Arial" pitchFamily="34" charset="-120"/>
@@ -1268,6 +1289,9 @@
                 <a:solidFill>
                   <a:srgbClr val="000000"/>
                 </a:solidFill>
+                <a:highlight>
+                  <a:srgbClr val="FFFF00"/>
+                </a:highlight>
                 <a:latin typeface="Arial" pitchFamily="34" charset="0"/>
                 <a:ea typeface="Arial" pitchFamily="34" charset="-122"/>
                 <a:cs typeface="Arial" pitchFamily="34" charset="-120"/>
@@ -1286,7 +1310,7 @@
         </p:nvSpPr>
         <p:spPr>
           <a:xfrm>
-            <a:off x="20285202" y="909447"/>
+            <a:off x="20285202" y="922020"/>
             <a:ext cx="715772" cy="12700"/>
           </a:xfrm>
           <a:prstGeom prst="rect">
@@ -1300,7 +1324,7 @@
       </p:sp>
       <p:sp>
         <p:nvSpPr>
-          <p:cNvPr id="14" name="arial-mixed-18-36__c43.20_t40.62"/>
+          <p:cNvPr id="14" name="arial-mixed-18-36__c43.20_t41.73"/>
           <p:cNvSpPr/>
           <p:nvPr/>
         </p:nvSpPr>
@@ -1334,6 +1358,9 @@
                 <a:solidFill>
                   <a:srgbClr val="000000"/>
                 </a:solidFill>
+                <a:highlight>
+                  <a:srgbClr val="FFFF00"/>
+                </a:highlight>
                 <a:latin typeface="Arial" pitchFamily="34" charset="0"/>
                 <a:ea typeface="Arial" pitchFamily="34" charset="-122"/>
                 <a:cs typeface="Arial" pitchFamily="34" charset="-120"/>
@@ -1351,6 +1378,9 @@
                 <a:solidFill>
                   <a:srgbClr val="000000"/>
                 </a:solidFill>
+                <a:highlight>
+                  <a:srgbClr val="FFFF00"/>
+                </a:highlight>
                 <a:latin typeface="Arial" pitchFamily="34" charset="0"/>
                 <a:ea typeface="Arial" pitchFamily="34" charset="-122"/>
                 <a:cs typeface="Arial" pitchFamily="34" charset="-120"/>
@@ -1368,6 +1398,9 @@
                 <a:solidFill>
                   <a:srgbClr val="000000"/>
                 </a:solidFill>
+                <a:highlight>
+                  <a:srgbClr val="FFFF00"/>
+                </a:highlight>
                 <a:latin typeface="Arial" pitchFamily="34" charset="0"/>
                 <a:ea typeface="Arial" pitchFamily="34" charset="-122"/>
                 <a:cs typeface="Arial" pitchFamily="34" charset="-120"/>
@@ -1386,7 +1419,7 @@
         </p:nvSpPr>
         <p:spPr>
           <a:xfrm>
-            <a:off x="21305774" y="966724"/>
+            <a:off x="21305774" y="980821"/>
             <a:ext cx="1981454" cy="12700"/>
           </a:xfrm>
           <a:prstGeom prst="rect">
@@ -1434,6 +1467,9 @@
                 <a:solidFill>
                   <a:srgbClr val="000000"/>
                 </a:solidFill>
+                <a:highlight>
+                  <a:srgbClr val="FFFF00"/>
+                </a:highlight>
                 <a:latin typeface="Arial" pitchFamily="34" charset="0"/>
                 <a:ea typeface="Arial" pitchFamily="34" charset="-122"/>
                 <a:cs typeface="Arial" pitchFamily="34" charset="-120"/>
@@ -1500,6 +1536,9 @@
                 <a:solidFill>
                   <a:srgbClr val="000000"/>
                 </a:solidFill>
+                <a:highlight>
+                  <a:srgbClr val="FFFF00"/>
+                </a:highlight>
                 <a:latin typeface="Arial" pitchFamily="34" charset="0"/>
                 <a:ea typeface="Arial" pitchFamily="34" charset="-122"/>
                 <a:cs typeface="Arial" pitchFamily="34" charset="-120"/>
@@ -1532,7 +1571,7 @@
       </p:sp>
       <p:sp>
         <p:nvSpPr>
-          <p:cNvPr id="20" name="arial-caps-18__c21.60_t20.31"/>
+          <p:cNvPr id="20" name="arial-caps-18__c21.60_t20.87"/>
           <p:cNvSpPr/>
           <p:nvPr/>
         </p:nvSpPr>
@@ -1566,6 +1605,9 @@
                 <a:solidFill>
                   <a:srgbClr val="000000"/>
                 </a:solidFill>
+                <a:highlight>
+                  <a:srgbClr val="FFFF00"/>
+                </a:highlight>
                 <a:latin typeface="Arial" pitchFamily="34" charset="0"/>
                 <a:ea typeface="Arial" pitchFamily="34" charset="-122"/>
                 <a:cs typeface="Arial" pitchFamily="34" charset="-120"/>
@@ -1584,7 +1626,7 @@
         </p:nvSpPr>
         <p:spPr>
           <a:xfrm>
-            <a:off x="29056584" y="708787"/>
+            <a:off x="29056584" y="715899"/>
             <a:ext cx="4331589" cy="12700"/>
           </a:xfrm>
           <a:prstGeom prst="rect">
@@ -1598,7 +1640,7 @@
       </p:sp>
       <p:sp>
         <p:nvSpPr>
-          <p:cNvPr id="22" name="arial-caps-32__c38.40_t36.11"/>
+          <p:cNvPr id="22" name="arial-caps-32__c38.40_t37.10"/>
           <p:cNvSpPr/>
           <p:nvPr/>
         </p:nvSpPr>
@@ -1632,6 +1674,9 @@
                 <a:solidFill>
                   <a:srgbClr val="000000"/>
                 </a:solidFill>
+                <a:highlight>
+                  <a:srgbClr val="FFFF00"/>
+                </a:highlight>
                 <a:latin typeface="Arial" pitchFamily="34" charset="0"/>
                 <a:ea typeface="Arial" pitchFamily="34" charset="-122"/>
                 <a:cs typeface="Arial" pitchFamily="34" charset="-120"/>
@@ -1650,7 +1695,7 @@
         </p:nvSpPr>
         <p:spPr>
           <a:xfrm>
-            <a:off x="33692973" y="909447"/>
+            <a:off x="33692973" y="922020"/>
             <a:ext cx="5239766" cy="12700"/>
           </a:xfrm>
           <a:prstGeom prst="rect">
@@ -1664,7 +1709,7 @@
       </p:sp>
       <p:sp>
         <p:nvSpPr>
-          <p:cNvPr id="24" name="arial-caps-40-bold__c48.00_t45.14"/>
+          <p:cNvPr id="24" name="arial-caps-40-bold__c48.00_t46.38"/>
           <p:cNvSpPr/>
           <p:nvPr/>
         </p:nvSpPr>
@@ -1698,6 +1743,9 @@
                 <a:solidFill>
                   <a:srgbClr val="000000"/>
                 </a:solidFill>
+                <a:highlight>
+                  <a:srgbClr val="FFFF00"/>
+                </a:highlight>
                 <a:latin typeface="Arial" pitchFamily="34" charset="0"/>
                 <a:ea typeface="Arial" pitchFamily="34" charset="-122"/>
                 <a:cs typeface="Arial" pitchFamily="34" charset="-120"/>
@@ -1716,7 +1764,7 @@
         </p:nvSpPr>
         <p:spPr>
           <a:xfrm>
-            <a:off x="39237539" y="1024128"/>
+            <a:off x="39237539" y="1039876"/>
             <a:ext cx="7068820" cy="12700"/>
           </a:xfrm>
           <a:prstGeom prst="rect">
@@ -1730,7 +1778,7 @@
       </p:sp>
       <p:sp>
         <p:nvSpPr>
-          <p:cNvPr id="26" name="arial-mixed-12-32-caps__c38.40_t36.11"/>
+          <p:cNvPr id="26" name="arial-mixed-12-32-caps__c38.40_t37.10"/>
           <p:cNvSpPr/>
           <p:nvPr/>
         </p:nvSpPr>
@@ -1764,6 +1812,9 @@
                 <a:solidFill>
                   <a:srgbClr val="000000"/>
                 </a:solidFill>
+                <a:highlight>
+                  <a:srgbClr val="FFFF00"/>
+                </a:highlight>
                 <a:latin typeface="Arial" pitchFamily="34" charset="0"/>
                 <a:ea typeface="Arial" pitchFamily="34" charset="-122"/>
                 <a:cs typeface="Arial" pitchFamily="34" charset="-120"/>
@@ -1781,6 +1832,9 @@
                 <a:solidFill>
                   <a:srgbClr val="000000"/>
                 </a:solidFill>
+                <a:highlight>
+                  <a:srgbClr val="FFFF00"/>
+                </a:highlight>
                 <a:latin typeface="Arial" pitchFamily="34" charset="0"/>
                 <a:ea typeface="Arial" pitchFamily="34" charset="-122"/>
                 <a:cs typeface="Arial" pitchFamily="34" charset="-120"/>
@@ -1798,6 +1852,9 @@
                 <a:solidFill>
                   <a:srgbClr val="000000"/>
                 </a:solidFill>
+                <a:highlight>
+                  <a:srgbClr val="FFFF00"/>
+                </a:highlight>
                 <a:latin typeface="Arial" pitchFamily="34" charset="0"/>
                 <a:ea typeface="Arial" pitchFamily="34" charset="-122"/>
                 <a:cs typeface="Arial" pitchFamily="34" charset="-120"/>
@@ -1816,7 +1873,7 @@
         </p:nvSpPr>
         <p:spPr>
           <a:xfrm>
-            <a:off x="46611159" y="909447"/>
+            <a:off x="46611159" y="922020"/>
             <a:ext cx="809371" cy="12700"/>
           </a:xfrm>
           <a:prstGeom prst="rect">
@@ -1864,6 +1921,9 @@
                 <a:solidFill>
                   <a:srgbClr val="000000"/>
                 </a:solidFill>
+                <a:highlight>
+                  <a:srgbClr val="FFFF00"/>
+                </a:highlight>
                 <a:latin typeface="Arial" pitchFamily="34" charset="0"/>
                 <a:ea typeface="Arial" pitchFamily="34" charset="-122"/>
                 <a:cs typeface="Arial" pitchFamily="34" charset="-120"/>
@@ -1930,6 +1990,9 @@
                 <a:solidFill>
                   <a:srgbClr val="000000"/>
                 </a:solidFill>
+                <a:highlight>
+                  <a:srgbClr val="FFFF00"/>
+                </a:highlight>
                 <a:latin typeface="Arial" pitchFamily="34" charset="0"/>
                 <a:ea typeface="Arial" pitchFamily="34" charset="-122"/>
                 <a:cs typeface="Arial" pitchFamily="34" charset="-120"/>

</xml_diff>